<commit_message>
Clarify study exposition and resolve source and illustration issues
</commit_message>
<xml_diff>
--- a/Studies/The-Epistemology-of-Coexistence/Epistemology-in-Comparison-MD-Advaita-Philosophy-Science.pptx
+++ b/Studies/The-Epistemology-of-Coexistence/Epistemology-in-Comparison-MD-Advaita-Philosophy-Science.pptx
@@ -4781,7 +4781,7 @@
                 <a:ea typeface="Calibri"/>
                 <a:cs typeface="Calibri"/>
               </a:rPr>
-              <a:t>Study §§1.7–1.8, 2.6, 3.1–3.2, 4.1–4.4, 5.3  ·  AnalyticMadhyasthDarshan.org  ·  10 / 12</a:t>
+              <a:t>Study §§1.5–1.6, 2.6, 3.1–3.2, 4.1–4.4, 5.3  ·  AnalyticMadhyasthDarshan.org  ·  10 / 12</a:t>
             </a:r>
           </a:p>
         </p:txBody>
@@ -16998,7 +16998,7 @@
                 <a:ea typeface="Calibri"/>
                 <a:cs typeface="Calibri"/>
               </a:rPr>
-              <a:t>Study §§1.4, 2.1–2.4, 3.3–3.7, 4.2  ·  AnalyticMadhyasthDarshan.org  ·  9 / 12</a:t>
+              <a:t>Study §§1.1, 1.3, 2.1–2.4, 3.3–3.7, 4.2  ·  AnalyticMadhyasthDarshan.org  ·  9 / 12</a:t>
             </a:r>
           </a:p>
         </p:txBody>

</xml_diff>